<commit_message>
ncar template: reduce body text sizes so content fits without autofit
Body placeholders were 28/24/20/18/14pt (32pt on the caption layouts'
content pane), so nearly every pandoc-generated slide overflowed its
placeholder. With enable_autofit.py switching every placeholder to
"Shrink text on overflow", PowerPoint's autofit then squeezed line
spacing to its 0.8 floor (lnSpcReduction 20000) on recompute -- the
"why is my line spacing 0.8?" squish. Nothing in the template ever set
0.8; the master styles are explicitly 100%.

Drop the master bodyStyle to 20/18/16/14/12pt and rescale the layouts
that carry their own overrides (Two Content, Comparison, Content/
Picture with Caption) to match; small caption tiers are untouched.
Typical content now fits at full line spacing, with autofit remaining
as a safety net for genuine overflow.

Co-Authored-By: Claude Fable 5 <noreply@anthropic.com>
</commit_message>
<xml_diff>
--- a/docs/common/branding/ncar/template.pptx
+++ b/docs/common/branding/ncar/template.pptx
@@ -2384,35 +2384,35 @@
             <a:lvl1pPr>
               <a:buFont typeface="Arial" panose="020B0604020202020204" pitchFamily="34" charset="0"/>
               <a:buChar char="•"/>
-              <a:defRPr sz="2800"/>
+              <a:defRPr sz="2000"/>
             </a:lvl1pPr>
             <a:lvl2pPr marL="457200" indent="-228600">
               <a:buFont typeface="Wingdings" pitchFamily="2" charset="2"/>
               <a:buChar char="§"/>
-              <a:defRPr sz="2400"/>
+              <a:defRPr sz="1800"/>
             </a:lvl2pPr>
             <a:lvl3pPr marL="914400" indent="-228600">
               <a:buFont typeface="Courier New" panose="02070309020205020404" pitchFamily="49" charset="0"/>
               <a:buChar char="o"/>
-              <a:defRPr sz="2000"/>
+              <a:defRPr sz="1600"/>
             </a:lvl3pPr>
             <a:lvl4pPr marL="1371600" indent="-228600">
-              <a:defRPr sz="1800"/>
+              <a:defRPr sz="1400"/>
             </a:lvl4pPr>
             <a:lvl5pPr marL="1600200" indent="-228600">
-              <a:defRPr sz="1800"/>
+              <a:defRPr sz="1200"/>
             </a:lvl5pPr>
             <a:lvl6pPr>
-              <a:defRPr sz="1800"/>
+              <a:defRPr sz="1200"/>
             </a:lvl6pPr>
             <a:lvl7pPr>
-              <a:defRPr sz="1800"/>
+              <a:defRPr sz="1200"/>
             </a:lvl7pPr>
             <a:lvl8pPr>
-              <a:defRPr sz="1800"/>
+              <a:defRPr sz="1200"/>
             </a:lvl8pPr>
             <a:lvl9pPr>
-              <a:defRPr sz="1800"/>
+              <a:defRPr sz="1200"/>
             </a:lvl9pPr>
           </a:lstStyle>
           <a:p>
@@ -2477,35 +2477,35 @@
             <a:lvl1pPr>
               <a:buFont typeface="Arial" panose="020B0604020202020204" pitchFamily="34" charset="0"/>
               <a:buChar char="•"/>
-              <a:defRPr sz="2800"/>
+              <a:defRPr sz="2000"/>
             </a:lvl1pPr>
             <a:lvl2pPr marL="457200" indent="-228600">
               <a:buFont typeface="Wingdings" pitchFamily="2" charset="2"/>
               <a:buChar char="§"/>
-              <a:defRPr sz="2400"/>
+              <a:defRPr sz="1800"/>
             </a:lvl2pPr>
             <a:lvl3pPr marL="914400" indent="-228600">
               <a:buFont typeface="Courier New" panose="02070309020205020404" pitchFamily="49" charset="0"/>
               <a:buChar char="o"/>
-              <a:defRPr sz="2000"/>
+              <a:defRPr sz="1600"/>
             </a:lvl3pPr>
             <a:lvl4pPr marL="1371600" indent="-228600">
-              <a:defRPr sz="1800"/>
+              <a:defRPr sz="1400"/>
             </a:lvl4pPr>
             <a:lvl5pPr marL="1600200" indent="-228600">
-              <a:defRPr sz="1800"/>
+              <a:defRPr sz="1200"/>
             </a:lvl5pPr>
             <a:lvl6pPr>
-              <a:defRPr sz="1800"/>
+              <a:defRPr sz="1200"/>
             </a:lvl6pPr>
             <a:lvl7pPr>
-              <a:defRPr sz="1800"/>
+              <a:defRPr sz="1200"/>
             </a:lvl7pPr>
             <a:lvl8pPr>
-              <a:defRPr sz="1800"/>
+              <a:defRPr sz="1200"/>
             </a:lvl8pPr>
             <a:lvl9pPr>
-              <a:defRPr sz="1800"/>
+              <a:defRPr sz="1200"/>
             </a:lvl9pPr>
           </a:lstStyle>
           <a:p>
@@ -2852,39 +2852,39 @@
           <a:lstStyle>
             <a:lvl1pPr marL="0" indent="0" algn="ctr">
               <a:buNone/>
-              <a:defRPr sz="2400" b="1"/>
+              <a:defRPr sz="1800" b="1"/>
             </a:lvl1pPr>
             <a:lvl2pPr marL="457189" indent="0">
               <a:buNone/>
-              <a:defRPr sz="2000" b="1"/>
+              <a:defRPr sz="1600" b="1"/>
             </a:lvl2pPr>
             <a:lvl3pPr marL="914377" indent="0">
               <a:buNone/>
-              <a:defRPr sz="1800" b="1"/>
+              <a:defRPr sz="1400" b="1"/>
             </a:lvl3pPr>
             <a:lvl4pPr marL="1371566" indent="0">
               <a:buNone/>
-              <a:defRPr sz="1600" b="1"/>
+              <a:defRPr sz="1200" b="1"/>
             </a:lvl4pPr>
             <a:lvl5pPr marL="1828754" indent="0">
               <a:buNone/>
-              <a:defRPr sz="1600" b="1"/>
+              <a:defRPr sz="1200" b="1"/>
             </a:lvl5pPr>
             <a:lvl6pPr marL="2285943" indent="0">
               <a:buNone/>
-              <a:defRPr sz="1600" b="1"/>
+              <a:defRPr sz="1200" b="1"/>
             </a:lvl6pPr>
             <a:lvl7pPr marL="2743131" indent="0">
               <a:buNone/>
-              <a:defRPr sz="1600" b="1"/>
+              <a:defRPr sz="1200" b="1"/>
             </a:lvl7pPr>
             <a:lvl8pPr marL="3200320" indent="0">
               <a:buNone/>
-              <a:defRPr sz="1600" b="1"/>
+              <a:defRPr sz="1200" b="1"/>
             </a:lvl8pPr>
             <a:lvl9pPr marL="3657509" indent="0">
               <a:buNone/>
-              <a:defRPr sz="1600" b="1"/>
+              <a:defRPr sz="1200" b="1"/>
             </a:lvl9pPr>
           </a:lstStyle>
           <a:p>
@@ -2920,39 +2920,39 @@
           <a:lstStyle>
             <a:lvl1pPr marL="0" indent="0" algn="ctr">
               <a:buNone/>
-              <a:defRPr sz="2400" b="1"/>
+              <a:defRPr sz="1800" b="1"/>
             </a:lvl1pPr>
             <a:lvl2pPr marL="457189" indent="0">
               <a:buNone/>
-              <a:defRPr sz="2000" b="1"/>
+              <a:defRPr sz="1600" b="1"/>
             </a:lvl2pPr>
             <a:lvl3pPr marL="914377" indent="0">
               <a:buNone/>
-              <a:defRPr sz="1800" b="1"/>
+              <a:defRPr sz="1400" b="1"/>
             </a:lvl3pPr>
             <a:lvl4pPr marL="1371566" indent="0">
               <a:buNone/>
-              <a:defRPr sz="1600" b="1"/>
+              <a:defRPr sz="1200" b="1"/>
             </a:lvl4pPr>
             <a:lvl5pPr marL="1828754" indent="0">
               <a:buNone/>
-              <a:defRPr sz="1600" b="1"/>
+              <a:defRPr sz="1200" b="1"/>
             </a:lvl5pPr>
             <a:lvl6pPr marL="2285943" indent="0">
               <a:buNone/>
-              <a:defRPr sz="1600" b="1"/>
+              <a:defRPr sz="1200" b="1"/>
             </a:lvl6pPr>
             <a:lvl7pPr marL="2743131" indent="0">
               <a:buNone/>
-              <a:defRPr sz="1600" b="1"/>
+              <a:defRPr sz="1200" b="1"/>
             </a:lvl7pPr>
             <a:lvl8pPr marL="3200320" indent="0">
               <a:buNone/>
-              <a:defRPr sz="1600" b="1"/>
+              <a:defRPr sz="1200" b="1"/>
             </a:lvl8pPr>
             <a:lvl9pPr marL="3657509" indent="0">
               <a:buNone/>
-              <a:defRPr sz="1600" b="1"/>
+              <a:defRPr sz="1200" b="1"/>
             </a:lvl9pPr>
           </a:lstStyle>
           <a:p>
@@ -3045,35 +3045,35 @@
             <a:lvl1pPr>
               <a:buFont typeface="Arial" panose="020B0604020202020204" pitchFamily="34" charset="0"/>
               <a:buChar char="•"/>
-              <a:defRPr sz="2800"/>
+              <a:defRPr sz="2000"/>
             </a:lvl1pPr>
             <a:lvl2pPr marL="457200" indent="-228600">
               <a:buFont typeface="Wingdings" pitchFamily="2" charset="2"/>
               <a:buChar char="§"/>
-              <a:defRPr sz="2400"/>
+              <a:defRPr sz="1800"/>
             </a:lvl2pPr>
             <a:lvl3pPr marL="914400" indent="-228600">
               <a:buFont typeface="Courier New" panose="02070309020205020404" pitchFamily="49" charset="0"/>
               <a:buChar char="o"/>
-              <a:defRPr sz="2000"/>
+              <a:defRPr sz="1600"/>
             </a:lvl3pPr>
             <a:lvl4pPr marL="1371600" indent="-228600">
-              <a:defRPr sz="1800"/>
+              <a:defRPr sz="1400"/>
             </a:lvl4pPr>
             <a:lvl5pPr marL="1600200" indent="-228600">
-              <a:defRPr sz="1800"/>
+              <a:defRPr sz="1200"/>
             </a:lvl5pPr>
             <a:lvl6pPr>
-              <a:defRPr sz="1800"/>
+              <a:defRPr sz="1200"/>
             </a:lvl6pPr>
             <a:lvl7pPr>
-              <a:defRPr sz="1800"/>
+              <a:defRPr sz="1200"/>
             </a:lvl7pPr>
             <a:lvl8pPr>
-              <a:defRPr sz="1800"/>
+              <a:defRPr sz="1200"/>
             </a:lvl8pPr>
             <a:lvl9pPr>
-              <a:defRPr sz="1800"/>
+              <a:defRPr sz="1200"/>
             </a:lvl9pPr>
           </a:lstStyle>
           <a:p>
@@ -3144,35 +3144,35 @@
             <a:lvl1pPr>
               <a:buFont typeface="Arial" panose="020B0604020202020204" pitchFamily="34" charset="0"/>
               <a:buChar char="•"/>
-              <a:defRPr sz="2800"/>
+              <a:defRPr sz="2000"/>
             </a:lvl1pPr>
             <a:lvl2pPr marL="457200" indent="-228600">
               <a:buFont typeface="Wingdings" pitchFamily="2" charset="2"/>
               <a:buChar char="§"/>
-              <a:defRPr sz="2400"/>
+              <a:defRPr sz="1800"/>
             </a:lvl2pPr>
             <a:lvl3pPr marL="914400" indent="-228600">
               <a:buFont typeface="Courier New" panose="02070309020205020404" pitchFamily="49" charset="0"/>
               <a:buChar char="o"/>
-              <a:defRPr sz="2000"/>
+              <a:defRPr sz="1600"/>
             </a:lvl3pPr>
             <a:lvl4pPr marL="1371600" indent="-228600">
-              <a:defRPr sz="1800"/>
+              <a:defRPr sz="1400"/>
             </a:lvl4pPr>
             <a:lvl5pPr marL="1600200" indent="-228600">
-              <a:defRPr sz="1800"/>
+              <a:defRPr sz="1200"/>
             </a:lvl5pPr>
             <a:lvl6pPr>
-              <a:defRPr sz="1800"/>
+              <a:defRPr sz="1200"/>
             </a:lvl6pPr>
             <a:lvl7pPr>
-              <a:defRPr sz="1800"/>
+              <a:defRPr sz="1200"/>
             </a:lvl7pPr>
             <a:lvl8pPr>
-              <a:defRPr sz="1800"/>
+              <a:defRPr sz="1200"/>
             </a:lvl8pPr>
             <a:lvl9pPr>
-              <a:defRPr sz="1800"/>
+              <a:defRPr sz="1200"/>
             </a:lvl9pPr>
           </a:lstStyle>
           <a:p>
@@ -3390,35 +3390,35 @@
             <a:lvl1pPr>
               <a:buFont typeface="Arial" panose="020B0604020202020204" pitchFamily="34" charset="0"/>
               <a:buChar char="•"/>
-              <a:defRPr sz="3200"/>
+              <a:defRPr sz="2000"/>
             </a:lvl1pPr>
             <a:lvl2pPr>
               <a:buFont typeface="Wingdings" pitchFamily="2" charset="2"/>
               <a:buChar char="§"/>
-              <a:defRPr sz="2800"/>
+              <a:defRPr sz="1800"/>
             </a:lvl2pPr>
             <a:lvl3pPr>
               <a:buFont typeface="Courier New" panose="02070309020205020404" pitchFamily="49" charset="0"/>
               <a:buChar char="o"/>
-              <a:defRPr sz="2400"/>
+              <a:defRPr sz="1600"/>
             </a:lvl3pPr>
             <a:lvl4pPr>
-              <a:defRPr sz="2000"/>
+              <a:defRPr sz="1400"/>
             </a:lvl4pPr>
             <a:lvl5pPr>
-              <a:defRPr sz="2000"/>
+              <a:defRPr sz="1200"/>
             </a:lvl5pPr>
             <a:lvl6pPr>
-              <a:defRPr sz="2000"/>
+              <a:defRPr sz="1200"/>
             </a:lvl6pPr>
             <a:lvl7pPr>
-              <a:defRPr sz="2000"/>
+              <a:defRPr sz="1200"/>
             </a:lvl7pPr>
             <a:lvl8pPr>
-              <a:defRPr sz="2000"/>
+              <a:defRPr sz="1200"/>
             </a:lvl8pPr>
             <a:lvl9pPr>
-              <a:defRPr sz="2000"/>
+              <a:defRPr sz="1200"/>
             </a:lvl9pPr>
           </a:lstStyle>
           <a:p>
@@ -3833,39 +3833,39 @@
           <a:lstStyle>
             <a:lvl1pPr marL="0" indent="0">
               <a:buNone/>
-              <a:defRPr sz="3200"/>
+              <a:defRPr sz="2000"/>
             </a:lvl1pPr>
             <a:lvl2pPr marL="457189" indent="0">
               <a:buNone/>
-              <a:defRPr sz="2800"/>
+              <a:defRPr sz="1800"/>
             </a:lvl2pPr>
             <a:lvl3pPr marL="914377" indent="0">
               <a:buNone/>
-              <a:defRPr sz="2400"/>
+              <a:defRPr sz="1600"/>
             </a:lvl3pPr>
             <a:lvl4pPr marL="1371566" indent="0">
               <a:buNone/>
-              <a:defRPr sz="2000"/>
+              <a:defRPr sz="1400"/>
             </a:lvl4pPr>
             <a:lvl5pPr marL="1828754" indent="0">
               <a:buNone/>
-              <a:defRPr sz="2000"/>
+              <a:defRPr sz="1200"/>
             </a:lvl5pPr>
             <a:lvl6pPr marL="2285943" indent="0">
               <a:buNone/>
-              <a:defRPr sz="2000"/>
+              <a:defRPr sz="1200"/>
             </a:lvl6pPr>
             <a:lvl7pPr marL="2743131" indent="0">
               <a:buNone/>
-              <a:defRPr sz="2000"/>
+              <a:defRPr sz="1200"/>
             </a:lvl7pPr>
             <a:lvl8pPr marL="3200320" indent="0">
               <a:buNone/>
-              <a:defRPr sz="2000"/>
+              <a:defRPr sz="1200"/>
             </a:lvl8pPr>
             <a:lvl9pPr marL="3657509" indent="0">
               <a:buNone/>
-              <a:defRPr sz="2000"/>
+              <a:defRPr sz="1200"/>
             </a:lvl9pPr>
           </a:lstStyle>
           <a:p>
@@ -4669,7 +4669,7 @@
         </a:spcBef>
         <a:buFont typeface="Arial" panose="020B0604020202020204" pitchFamily="34" charset="0"/>
         <a:buChar char="•"/>
-        <a:defRPr sz="2800" b="0" kern="1200" baseline="0">
+        <a:defRPr sz="2000" b="0" kern="1200" baseline="0">
           <a:solidFill>
             <a:schemeClr val="tx1"/>
           </a:solidFill>
@@ -4687,7 +4687,7 @@
         </a:spcBef>
         <a:buFont typeface="Wingdings" pitchFamily="2" charset="2"/>
         <a:buChar char="§"/>
-        <a:defRPr sz="2400" kern="1200" baseline="0">
+        <a:defRPr sz="1800" kern="1200" baseline="0">
           <a:solidFill>
             <a:schemeClr val="tx1"/>
           </a:solidFill>
@@ -4705,7 +4705,7 @@
         </a:spcBef>
         <a:buFont typeface="Courier New" panose="02070309020205020404" pitchFamily="49" charset="0"/>
         <a:buChar char="o"/>
-        <a:defRPr sz="2000" kern="1200" baseline="0">
+        <a:defRPr sz="1600" kern="1200" baseline="0">
           <a:solidFill>
             <a:schemeClr val="tx1"/>
           </a:solidFill>
@@ -4723,7 +4723,7 @@
         </a:spcBef>
         <a:buFont typeface="Arial"/>
         <a:buChar char="–"/>
-        <a:defRPr sz="1800" kern="1200" baseline="0">
+        <a:defRPr sz="1400" kern="1200" baseline="0">
           <a:solidFill>
             <a:schemeClr val="tx1"/>
           </a:solidFill>
@@ -4741,7 +4741,7 @@
         </a:spcBef>
         <a:buFont typeface="Arial"/>
         <a:buChar char="»"/>
-        <a:defRPr sz="1400" kern="1200" baseline="0">
+        <a:defRPr sz="1200" kern="1200" baseline="0">
           <a:solidFill>
             <a:schemeClr val="tx1"/>
           </a:solidFill>
@@ -4756,7 +4756,7 @@
         </a:spcBef>
         <a:buFont typeface="Arial"/>
         <a:buChar char="•"/>
-        <a:defRPr sz="2000" kern="1200">
+        <a:defRPr sz="1200" kern="1200">
           <a:solidFill>
             <a:schemeClr val="tx1"/>
           </a:solidFill>
@@ -4771,7 +4771,7 @@
         </a:spcBef>
         <a:buFont typeface="Arial"/>
         <a:buChar char="•"/>
-        <a:defRPr sz="2000" kern="1200">
+        <a:defRPr sz="1200" kern="1200">
           <a:solidFill>
             <a:schemeClr val="tx1"/>
           </a:solidFill>
@@ -4786,7 +4786,7 @@
         </a:spcBef>
         <a:buFont typeface="Arial"/>
         <a:buChar char="•"/>
-        <a:defRPr sz="2000" kern="1200">
+        <a:defRPr sz="1200" kern="1200">
           <a:solidFill>
             <a:schemeClr val="tx1"/>
           </a:solidFill>
@@ -4801,7 +4801,7 @@
         </a:spcBef>
         <a:buFont typeface="Arial"/>
         <a:buChar char="•"/>
-        <a:defRPr sz="2000" kern="1200">
+        <a:defRPr sz="1200" kern="1200">
           <a:solidFill>
             <a:schemeClr val="tx1"/>
           </a:solidFill>

</xml_diff>

<commit_message>
sam_and_pbs: SAM & PBS integration deck (+ template fix, diagram tooling) (#2)
</commit_message>
<xml_diff>
--- a/docs/common/branding/ncar/template.pptx
+++ b/docs/common/branding/ncar/template.pptx
@@ -2384,35 +2384,35 @@
             <a:lvl1pPr>
               <a:buFont typeface="Arial" panose="020B0604020202020204" pitchFamily="34" charset="0"/>
               <a:buChar char="•"/>
-              <a:defRPr sz="2800"/>
+              <a:defRPr sz="2000"/>
             </a:lvl1pPr>
             <a:lvl2pPr marL="457200" indent="-228600">
               <a:buFont typeface="Wingdings" pitchFamily="2" charset="2"/>
               <a:buChar char="§"/>
-              <a:defRPr sz="2400"/>
+              <a:defRPr sz="1800"/>
             </a:lvl2pPr>
             <a:lvl3pPr marL="914400" indent="-228600">
               <a:buFont typeface="Courier New" panose="02070309020205020404" pitchFamily="49" charset="0"/>
               <a:buChar char="o"/>
-              <a:defRPr sz="2000"/>
+              <a:defRPr sz="1600"/>
             </a:lvl3pPr>
             <a:lvl4pPr marL="1371600" indent="-228600">
-              <a:defRPr sz="1800"/>
+              <a:defRPr sz="1400"/>
             </a:lvl4pPr>
             <a:lvl5pPr marL="1600200" indent="-228600">
-              <a:defRPr sz="1800"/>
+              <a:defRPr sz="1200"/>
             </a:lvl5pPr>
             <a:lvl6pPr>
-              <a:defRPr sz="1800"/>
+              <a:defRPr sz="1200"/>
             </a:lvl6pPr>
             <a:lvl7pPr>
-              <a:defRPr sz="1800"/>
+              <a:defRPr sz="1200"/>
             </a:lvl7pPr>
             <a:lvl8pPr>
-              <a:defRPr sz="1800"/>
+              <a:defRPr sz="1200"/>
             </a:lvl8pPr>
             <a:lvl9pPr>
-              <a:defRPr sz="1800"/>
+              <a:defRPr sz="1200"/>
             </a:lvl9pPr>
           </a:lstStyle>
           <a:p>
@@ -2477,35 +2477,35 @@
             <a:lvl1pPr>
               <a:buFont typeface="Arial" panose="020B0604020202020204" pitchFamily="34" charset="0"/>
               <a:buChar char="•"/>
-              <a:defRPr sz="2800"/>
+              <a:defRPr sz="2000"/>
             </a:lvl1pPr>
             <a:lvl2pPr marL="457200" indent="-228600">
               <a:buFont typeface="Wingdings" pitchFamily="2" charset="2"/>
               <a:buChar char="§"/>
-              <a:defRPr sz="2400"/>
+              <a:defRPr sz="1800"/>
             </a:lvl2pPr>
             <a:lvl3pPr marL="914400" indent="-228600">
               <a:buFont typeface="Courier New" panose="02070309020205020404" pitchFamily="49" charset="0"/>
               <a:buChar char="o"/>
-              <a:defRPr sz="2000"/>
+              <a:defRPr sz="1600"/>
             </a:lvl3pPr>
             <a:lvl4pPr marL="1371600" indent="-228600">
-              <a:defRPr sz="1800"/>
+              <a:defRPr sz="1400"/>
             </a:lvl4pPr>
             <a:lvl5pPr marL="1600200" indent="-228600">
-              <a:defRPr sz="1800"/>
+              <a:defRPr sz="1200"/>
             </a:lvl5pPr>
             <a:lvl6pPr>
-              <a:defRPr sz="1800"/>
+              <a:defRPr sz="1200"/>
             </a:lvl6pPr>
             <a:lvl7pPr>
-              <a:defRPr sz="1800"/>
+              <a:defRPr sz="1200"/>
             </a:lvl7pPr>
             <a:lvl8pPr>
-              <a:defRPr sz="1800"/>
+              <a:defRPr sz="1200"/>
             </a:lvl8pPr>
             <a:lvl9pPr>
-              <a:defRPr sz="1800"/>
+              <a:defRPr sz="1200"/>
             </a:lvl9pPr>
           </a:lstStyle>
           <a:p>
@@ -2852,39 +2852,39 @@
           <a:lstStyle>
             <a:lvl1pPr marL="0" indent="0" algn="ctr">
               <a:buNone/>
-              <a:defRPr sz="2400" b="1"/>
+              <a:defRPr sz="1800" b="1"/>
             </a:lvl1pPr>
             <a:lvl2pPr marL="457189" indent="0">
               <a:buNone/>
-              <a:defRPr sz="2000" b="1"/>
+              <a:defRPr sz="1600" b="1"/>
             </a:lvl2pPr>
             <a:lvl3pPr marL="914377" indent="0">
               <a:buNone/>
-              <a:defRPr sz="1800" b="1"/>
+              <a:defRPr sz="1400" b="1"/>
             </a:lvl3pPr>
             <a:lvl4pPr marL="1371566" indent="0">
               <a:buNone/>
-              <a:defRPr sz="1600" b="1"/>
+              <a:defRPr sz="1200" b="1"/>
             </a:lvl4pPr>
             <a:lvl5pPr marL="1828754" indent="0">
               <a:buNone/>
-              <a:defRPr sz="1600" b="1"/>
+              <a:defRPr sz="1200" b="1"/>
             </a:lvl5pPr>
             <a:lvl6pPr marL="2285943" indent="0">
               <a:buNone/>
-              <a:defRPr sz="1600" b="1"/>
+              <a:defRPr sz="1200" b="1"/>
             </a:lvl6pPr>
             <a:lvl7pPr marL="2743131" indent="0">
               <a:buNone/>
-              <a:defRPr sz="1600" b="1"/>
+              <a:defRPr sz="1200" b="1"/>
             </a:lvl7pPr>
             <a:lvl8pPr marL="3200320" indent="0">
               <a:buNone/>
-              <a:defRPr sz="1600" b="1"/>
+              <a:defRPr sz="1200" b="1"/>
             </a:lvl8pPr>
             <a:lvl9pPr marL="3657509" indent="0">
               <a:buNone/>
-              <a:defRPr sz="1600" b="1"/>
+              <a:defRPr sz="1200" b="1"/>
             </a:lvl9pPr>
           </a:lstStyle>
           <a:p>
@@ -2920,39 +2920,39 @@
           <a:lstStyle>
             <a:lvl1pPr marL="0" indent="0" algn="ctr">
               <a:buNone/>
-              <a:defRPr sz="2400" b="1"/>
+              <a:defRPr sz="1800" b="1"/>
             </a:lvl1pPr>
             <a:lvl2pPr marL="457189" indent="0">
               <a:buNone/>
-              <a:defRPr sz="2000" b="1"/>
+              <a:defRPr sz="1600" b="1"/>
             </a:lvl2pPr>
             <a:lvl3pPr marL="914377" indent="0">
               <a:buNone/>
-              <a:defRPr sz="1800" b="1"/>
+              <a:defRPr sz="1400" b="1"/>
             </a:lvl3pPr>
             <a:lvl4pPr marL="1371566" indent="0">
               <a:buNone/>
-              <a:defRPr sz="1600" b="1"/>
+              <a:defRPr sz="1200" b="1"/>
             </a:lvl4pPr>
             <a:lvl5pPr marL="1828754" indent="0">
               <a:buNone/>
-              <a:defRPr sz="1600" b="1"/>
+              <a:defRPr sz="1200" b="1"/>
             </a:lvl5pPr>
             <a:lvl6pPr marL="2285943" indent="0">
               <a:buNone/>
-              <a:defRPr sz="1600" b="1"/>
+              <a:defRPr sz="1200" b="1"/>
             </a:lvl6pPr>
             <a:lvl7pPr marL="2743131" indent="0">
               <a:buNone/>
-              <a:defRPr sz="1600" b="1"/>
+              <a:defRPr sz="1200" b="1"/>
             </a:lvl7pPr>
             <a:lvl8pPr marL="3200320" indent="0">
               <a:buNone/>
-              <a:defRPr sz="1600" b="1"/>
+              <a:defRPr sz="1200" b="1"/>
             </a:lvl8pPr>
             <a:lvl9pPr marL="3657509" indent="0">
               <a:buNone/>
-              <a:defRPr sz="1600" b="1"/>
+              <a:defRPr sz="1200" b="1"/>
             </a:lvl9pPr>
           </a:lstStyle>
           <a:p>
@@ -3045,35 +3045,35 @@
             <a:lvl1pPr>
               <a:buFont typeface="Arial" panose="020B0604020202020204" pitchFamily="34" charset="0"/>
               <a:buChar char="•"/>
-              <a:defRPr sz="2800"/>
+              <a:defRPr sz="2000"/>
             </a:lvl1pPr>
             <a:lvl2pPr marL="457200" indent="-228600">
               <a:buFont typeface="Wingdings" pitchFamily="2" charset="2"/>
               <a:buChar char="§"/>
-              <a:defRPr sz="2400"/>
+              <a:defRPr sz="1800"/>
             </a:lvl2pPr>
             <a:lvl3pPr marL="914400" indent="-228600">
               <a:buFont typeface="Courier New" panose="02070309020205020404" pitchFamily="49" charset="0"/>
               <a:buChar char="o"/>
-              <a:defRPr sz="2000"/>
+              <a:defRPr sz="1600"/>
             </a:lvl3pPr>
             <a:lvl4pPr marL="1371600" indent="-228600">
-              <a:defRPr sz="1800"/>
+              <a:defRPr sz="1400"/>
             </a:lvl4pPr>
             <a:lvl5pPr marL="1600200" indent="-228600">
-              <a:defRPr sz="1800"/>
+              <a:defRPr sz="1200"/>
             </a:lvl5pPr>
             <a:lvl6pPr>
-              <a:defRPr sz="1800"/>
+              <a:defRPr sz="1200"/>
             </a:lvl6pPr>
             <a:lvl7pPr>
-              <a:defRPr sz="1800"/>
+              <a:defRPr sz="1200"/>
             </a:lvl7pPr>
             <a:lvl8pPr>
-              <a:defRPr sz="1800"/>
+              <a:defRPr sz="1200"/>
             </a:lvl8pPr>
             <a:lvl9pPr>
-              <a:defRPr sz="1800"/>
+              <a:defRPr sz="1200"/>
             </a:lvl9pPr>
           </a:lstStyle>
           <a:p>
@@ -3144,35 +3144,35 @@
             <a:lvl1pPr>
               <a:buFont typeface="Arial" panose="020B0604020202020204" pitchFamily="34" charset="0"/>
               <a:buChar char="•"/>
-              <a:defRPr sz="2800"/>
+              <a:defRPr sz="2000"/>
             </a:lvl1pPr>
             <a:lvl2pPr marL="457200" indent="-228600">
               <a:buFont typeface="Wingdings" pitchFamily="2" charset="2"/>
               <a:buChar char="§"/>
-              <a:defRPr sz="2400"/>
+              <a:defRPr sz="1800"/>
             </a:lvl2pPr>
             <a:lvl3pPr marL="914400" indent="-228600">
               <a:buFont typeface="Courier New" panose="02070309020205020404" pitchFamily="49" charset="0"/>
               <a:buChar char="o"/>
-              <a:defRPr sz="2000"/>
+              <a:defRPr sz="1600"/>
             </a:lvl3pPr>
             <a:lvl4pPr marL="1371600" indent="-228600">
-              <a:defRPr sz="1800"/>
+              <a:defRPr sz="1400"/>
             </a:lvl4pPr>
             <a:lvl5pPr marL="1600200" indent="-228600">
-              <a:defRPr sz="1800"/>
+              <a:defRPr sz="1200"/>
             </a:lvl5pPr>
             <a:lvl6pPr>
-              <a:defRPr sz="1800"/>
+              <a:defRPr sz="1200"/>
             </a:lvl6pPr>
             <a:lvl7pPr>
-              <a:defRPr sz="1800"/>
+              <a:defRPr sz="1200"/>
             </a:lvl7pPr>
             <a:lvl8pPr>
-              <a:defRPr sz="1800"/>
+              <a:defRPr sz="1200"/>
             </a:lvl8pPr>
             <a:lvl9pPr>
-              <a:defRPr sz="1800"/>
+              <a:defRPr sz="1200"/>
             </a:lvl9pPr>
           </a:lstStyle>
           <a:p>
@@ -3390,35 +3390,35 @@
             <a:lvl1pPr>
               <a:buFont typeface="Arial" panose="020B0604020202020204" pitchFamily="34" charset="0"/>
               <a:buChar char="•"/>
-              <a:defRPr sz="3200"/>
+              <a:defRPr sz="2000"/>
             </a:lvl1pPr>
             <a:lvl2pPr>
               <a:buFont typeface="Wingdings" pitchFamily="2" charset="2"/>
               <a:buChar char="§"/>
-              <a:defRPr sz="2800"/>
+              <a:defRPr sz="1800"/>
             </a:lvl2pPr>
             <a:lvl3pPr>
               <a:buFont typeface="Courier New" panose="02070309020205020404" pitchFamily="49" charset="0"/>
               <a:buChar char="o"/>
-              <a:defRPr sz="2400"/>
+              <a:defRPr sz="1600"/>
             </a:lvl3pPr>
             <a:lvl4pPr>
-              <a:defRPr sz="2000"/>
+              <a:defRPr sz="1400"/>
             </a:lvl4pPr>
             <a:lvl5pPr>
-              <a:defRPr sz="2000"/>
+              <a:defRPr sz="1200"/>
             </a:lvl5pPr>
             <a:lvl6pPr>
-              <a:defRPr sz="2000"/>
+              <a:defRPr sz="1200"/>
             </a:lvl6pPr>
             <a:lvl7pPr>
-              <a:defRPr sz="2000"/>
+              <a:defRPr sz="1200"/>
             </a:lvl7pPr>
             <a:lvl8pPr>
-              <a:defRPr sz="2000"/>
+              <a:defRPr sz="1200"/>
             </a:lvl8pPr>
             <a:lvl9pPr>
-              <a:defRPr sz="2000"/>
+              <a:defRPr sz="1200"/>
             </a:lvl9pPr>
           </a:lstStyle>
           <a:p>
@@ -3833,39 +3833,39 @@
           <a:lstStyle>
             <a:lvl1pPr marL="0" indent="0">
               <a:buNone/>
-              <a:defRPr sz="3200"/>
+              <a:defRPr sz="2000"/>
             </a:lvl1pPr>
             <a:lvl2pPr marL="457189" indent="0">
               <a:buNone/>
-              <a:defRPr sz="2800"/>
+              <a:defRPr sz="1800"/>
             </a:lvl2pPr>
             <a:lvl3pPr marL="914377" indent="0">
               <a:buNone/>
-              <a:defRPr sz="2400"/>
+              <a:defRPr sz="1600"/>
             </a:lvl3pPr>
             <a:lvl4pPr marL="1371566" indent="0">
               <a:buNone/>
-              <a:defRPr sz="2000"/>
+              <a:defRPr sz="1400"/>
             </a:lvl4pPr>
             <a:lvl5pPr marL="1828754" indent="0">
               <a:buNone/>
-              <a:defRPr sz="2000"/>
+              <a:defRPr sz="1200"/>
             </a:lvl5pPr>
             <a:lvl6pPr marL="2285943" indent="0">
               <a:buNone/>
-              <a:defRPr sz="2000"/>
+              <a:defRPr sz="1200"/>
             </a:lvl6pPr>
             <a:lvl7pPr marL="2743131" indent="0">
               <a:buNone/>
-              <a:defRPr sz="2000"/>
+              <a:defRPr sz="1200"/>
             </a:lvl7pPr>
             <a:lvl8pPr marL="3200320" indent="0">
               <a:buNone/>
-              <a:defRPr sz="2000"/>
+              <a:defRPr sz="1200"/>
             </a:lvl8pPr>
             <a:lvl9pPr marL="3657509" indent="0">
               <a:buNone/>
-              <a:defRPr sz="2000"/>
+              <a:defRPr sz="1200"/>
             </a:lvl9pPr>
           </a:lstStyle>
           <a:p>
@@ -4669,7 +4669,7 @@
         </a:spcBef>
         <a:buFont typeface="Arial" panose="020B0604020202020204" pitchFamily="34" charset="0"/>
         <a:buChar char="•"/>
-        <a:defRPr sz="2800" b="0" kern="1200" baseline="0">
+        <a:defRPr sz="2000" b="0" kern="1200" baseline="0">
           <a:solidFill>
             <a:schemeClr val="tx1"/>
           </a:solidFill>
@@ -4687,7 +4687,7 @@
         </a:spcBef>
         <a:buFont typeface="Wingdings" pitchFamily="2" charset="2"/>
         <a:buChar char="§"/>
-        <a:defRPr sz="2400" kern="1200" baseline="0">
+        <a:defRPr sz="1800" kern="1200" baseline="0">
           <a:solidFill>
             <a:schemeClr val="tx1"/>
           </a:solidFill>
@@ -4705,7 +4705,7 @@
         </a:spcBef>
         <a:buFont typeface="Courier New" panose="02070309020205020404" pitchFamily="49" charset="0"/>
         <a:buChar char="o"/>
-        <a:defRPr sz="2000" kern="1200" baseline="0">
+        <a:defRPr sz="1600" kern="1200" baseline="0">
           <a:solidFill>
             <a:schemeClr val="tx1"/>
           </a:solidFill>
@@ -4723,7 +4723,7 @@
         </a:spcBef>
         <a:buFont typeface="Arial"/>
         <a:buChar char="–"/>
-        <a:defRPr sz="1800" kern="1200" baseline="0">
+        <a:defRPr sz="1400" kern="1200" baseline="0">
           <a:solidFill>
             <a:schemeClr val="tx1"/>
           </a:solidFill>
@@ -4741,7 +4741,7 @@
         </a:spcBef>
         <a:buFont typeface="Arial"/>
         <a:buChar char="»"/>
-        <a:defRPr sz="1400" kern="1200" baseline="0">
+        <a:defRPr sz="1200" kern="1200" baseline="0">
           <a:solidFill>
             <a:schemeClr val="tx1"/>
           </a:solidFill>
@@ -4756,7 +4756,7 @@
         </a:spcBef>
         <a:buFont typeface="Arial"/>
         <a:buChar char="•"/>
-        <a:defRPr sz="2000" kern="1200">
+        <a:defRPr sz="1200" kern="1200">
           <a:solidFill>
             <a:schemeClr val="tx1"/>
           </a:solidFill>
@@ -4771,7 +4771,7 @@
         </a:spcBef>
         <a:buFont typeface="Arial"/>
         <a:buChar char="•"/>
-        <a:defRPr sz="2000" kern="1200">
+        <a:defRPr sz="1200" kern="1200">
           <a:solidFill>
             <a:schemeClr val="tx1"/>
           </a:solidFill>
@@ -4786,7 +4786,7 @@
         </a:spcBef>
         <a:buFont typeface="Arial"/>
         <a:buChar char="•"/>
-        <a:defRPr sz="2000" kern="1200">
+        <a:defRPr sz="1200" kern="1200">
           <a:solidFill>
             <a:schemeClr val="tx1"/>
           </a:solidFill>
@@ -4801,7 +4801,7 @@
         </a:spcBef>
         <a:buFont typeface="Arial"/>
         <a:buChar char="•"/>
-        <a:defRPr sz="2000" kern="1200">
+        <a:defRPr sz="1200" kern="1200">
           <a:solidFill>
             <a:schemeClr val="tx1"/>
           </a:solidFill>

</xml_diff>